<commit_message>
Separate personal preparation notes from project documentation
</commit_message>
<xml_diff>
--- a/deliverables/HitPredict_Presentation.pptx
+++ b/deliverables/HitPredict_Presentation.pptx
@@ -2,24 +2,24 @@
 <file path=ppt/presentation.xml><?xml version="1.0" encoding="utf-8"?>
 <p:presentation xmlns:p="http://schemas.openxmlformats.org/presentationml/2006/main">
   <p:sldMasterIdLst>
-    <p:sldMasterId xmlns:r="http://schemas.openxmlformats.org/officeDocument/2006/relationships" id="2147483648" r:id="Rd0250485a528491e"/>
+    <p:sldMasterId xmlns:r="http://schemas.openxmlformats.org/officeDocument/2006/relationships" id="2147483648" r:id="Rcefa1e86a6184bc6"/>
   </p:sldMasterIdLst>
   <p:notesMasterIdLst>
-    <p:notesMasterId xmlns:r="http://schemas.openxmlformats.org/officeDocument/2006/relationships" r:id="R2c2aeae91a19498f"/>
+    <p:notesMasterId xmlns:r="http://schemas.openxmlformats.org/officeDocument/2006/relationships" r:id="R668b8468175d4984"/>
   </p:notesMasterIdLst>
   <p:sldIdLst>
-    <p:sldId xmlns:r="http://schemas.openxmlformats.org/officeDocument/2006/relationships" id="256" r:id="R9e2ad34098fc452b"/>
-    <p:sldId xmlns:r="http://schemas.openxmlformats.org/officeDocument/2006/relationships" id="257" r:id="Rc52f6a6274414d16"/>
-    <p:sldId xmlns:r="http://schemas.openxmlformats.org/officeDocument/2006/relationships" id="258" r:id="Re36bd946fcbd4fc2"/>
-    <p:sldId xmlns:r="http://schemas.openxmlformats.org/officeDocument/2006/relationships" id="259" r:id="R3e563f77eede448f"/>
-    <p:sldId xmlns:r="http://schemas.openxmlformats.org/officeDocument/2006/relationships" id="260" r:id="R4d76f360c7d04a4d"/>
-    <p:sldId xmlns:r="http://schemas.openxmlformats.org/officeDocument/2006/relationships" id="261" r:id="R7cfdb194b6134cca"/>
-    <p:sldId xmlns:r="http://schemas.openxmlformats.org/officeDocument/2006/relationships" id="262" r:id="R4b18c84425414934"/>
-    <p:sldId xmlns:r="http://schemas.openxmlformats.org/officeDocument/2006/relationships" id="263" r:id="R5f39f31fe8fc4504"/>
-    <p:sldId xmlns:r="http://schemas.openxmlformats.org/officeDocument/2006/relationships" id="264" r:id="R0aab8d67a1754fda"/>
-    <p:sldId xmlns:r="http://schemas.openxmlformats.org/officeDocument/2006/relationships" id="265" r:id="Re901752663004948"/>
-    <p:sldId xmlns:r="http://schemas.openxmlformats.org/officeDocument/2006/relationships" id="266" r:id="R308cbf0489b74a5b"/>
-    <p:sldId xmlns:r="http://schemas.openxmlformats.org/officeDocument/2006/relationships" id="267" r:id="R0157f3e80325405f"/>
+    <p:sldId xmlns:r="http://schemas.openxmlformats.org/officeDocument/2006/relationships" id="256" r:id="Rf5d91387a58a4c51"/>
+    <p:sldId xmlns:r="http://schemas.openxmlformats.org/officeDocument/2006/relationships" id="257" r:id="R8d6d43fc86ea4c62"/>
+    <p:sldId xmlns:r="http://schemas.openxmlformats.org/officeDocument/2006/relationships" id="258" r:id="R92aa7c947baf4ad1"/>
+    <p:sldId xmlns:r="http://schemas.openxmlformats.org/officeDocument/2006/relationships" id="259" r:id="R7eb164a087814bc4"/>
+    <p:sldId xmlns:r="http://schemas.openxmlformats.org/officeDocument/2006/relationships" id="260" r:id="R5e764cdacfc84c9b"/>
+    <p:sldId xmlns:r="http://schemas.openxmlformats.org/officeDocument/2006/relationships" id="261" r:id="Rfe85a7b41a4b4b63"/>
+    <p:sldId xmlns:r="http://schemas.openxmlformats.org/officeDocument/2006/relationships" id="262" r:id="R090bf05162974d07"/>
+    <p:sldId xmlns:r="http://schemas.openxmlformats.org/officeDocument/2006/relationships" id="263" r:id="Rb9cfe08393a64203"/>
+    <p:sldId xmlns:r="http://schemas.openxmlformats.org/officeDocument/2006/relationships" id="264" r:id="Rfe81cbaafffe469c"/>
+    <p:sldId xmlns:r="http://schemas.openxmlformats.org/officeDocument/2006/relationships" id="265" r:id="R835fe83ec8e24c57"/>
+    <p:sldId xmlns:r="http://schemas.openxmlformats.org/officeDocument/2006/relationships" id="266" r:id="R6bea04de250346fb"/>
+    <p:sldId xmlns:r="http://schemas.openxmlformats.org/officeDocument/2006/relationships" id="267" r:id="Rc5f7915ae774498b"/>
   </p:sldIdLst>
   <p:sldSz cx="12192000" cy="6858000"/>
   <p:notesSz cx="6858000" cy="9144000"/>
@@ -663,7 +663,7 @@
           <a:lstStyle xmlns:a="http://schemas.openxmlformats.org/drawingml/2006/main"/>
           <a:p xmlns:a="http://schemas.openxmlformats.org/drawingml/2006/main">
             <a:r>
-              <a:t>Summarize the finding without overstating it: useful historical classification signal, imperfect predictions, and a recall/precision trade-off. The next experiment requires verified release dates, track identity checks, representative non-hits, a fixed future chart window, temporal holdout and calibration. Original dataset and inspiration credited to Georgieva, Suta and Burton, Stanford CS229 (2018), https://cs229.stanford.edu/proj2018/report/16.pdf. This package used AI assistance; students must record their actual individual contributions separately.</a:t>
+              <a:t>The experiment finds useful historical classification signal with imperfect predictions and a recall/precision trade-off. The next experiment requires verified release dates, track identity checks, representative non-hits, a fixed future chart window, temporal holdout and calibration. Original dataset and inspiration credited to Georgieva, Suta and Burton, Stanford CS229 (2018), https://cs229.stanford.edu/proj2018/report/16.pdf.</a:t>
             </a:r>
           </a:p>
         </p:txBody>
@@ -1291,7 +1291,7 @@
   </p:cSld>
   <p:clrMap bg1="lt1" tx1="dk1" bg2="lt2" tx2="dk2" accent1="accent1" accent2="accent2" accent3="accent3" accent4="accent4" accent5="accent5" accent6="accent6" hlink="hlink" folHlink="folHlink"/>
   <p:sldLayoutIdLst>
-    <p:sldLayoutId xmlns:r="http://schemas.openxmlformats.org/officeDocument/2006/relationships" id="2147483649" r:id="R59f0c8934dc94be4"/>
+    <p:sldLayoutId xmlns:r="http://schemas.openxmlformats.org/officeDocument/2006/relationships" id="2147483649" r:id="Ra8590ea81c0c49dd"/>
   </p:sldLayoutIdLst>
   <p:txStyles>
     <p:titleStyle>
@@ -2254,7 +2254,7 @@
           <p:cNvPr id="6" name="">
             <a:extLst xmlns:a="http://schemas.openxmlformats.org/drawingml/2006/main">
               <a:ext uri="{FF2B5EF4-FFF2-40B4-BE49-F238E27FC236}">
-                <a16:creationId xmlns:a16="http://schemas.microsoft.com/office/drawing/2014/main" id="{2F0637DA-A3CF-408A-BD95-B95DD5919BB3}"/>
+                <a16:creationId xmlns:a16="http://schemas.microsoft.com/office/drawing/2014/main" id="{A4702B11-B40A-4F13-94CB-AA680668516A}"/>
               </a:ext>
             </a:extLst>
           </p:cNvPr>
@@ -2311,7 +2311,7 @@
           <p:cNvPr id="2" name="">
             <a:extLst xmlns:a="http://schemas.openxmlformats.org/drawingml/2006/main">
               <a:ext uri="{FF2B5EF4-FFF2-40B4-BE49-F238E27FC236}">
-                <a16:creationId xmlns:a16="http://schemas.microsoft.com/office/drawing/2014/main" id="{4FC588DD-DF3A-4B2E-99BA-A43FAC691BDD}"/>
+                <a16:creationId xmlns:a16="http://schemas.microsoft.com/office/drawing/2014/main" id="{2E111CA4-13BF-4E5D-85FC-37FCF59CCFB7}"/>
               </a:ext>
             </a:extLst>
           </p:cNvPr>
@@ -2391,7 +2391,7 @@
           <p:cNvPr id="3" name="">
             <a:extLst xmlns:a="http://schemas.openxmlformats.org/drawingml/2006/main">
               <a:ext uri="{FF2B5EF4-FFF2-40B4-BE49-F238E27FC236}">
-                <a16:creationId xmlns:a16="http://schemas.microsoft.com/office/drawing/2014/main" id="{C876703F-EDDC-42AD-A069-254436C59B8D}"/>
+                <a16:creationId xmlns:a16="http://schemas.microsoft.com/office/drawing/2014/main" id="{3974122F-0F17-4CC6-A761-7306E68AA678}"/>
               </a:ext>
             </a:extLst>
           </p:cNvPr>
@@ -2448,7 +2448,7 @@
           <p:cNvPr id="4" name="">
             <a:extLst xmlns:a="http://schemas.openxmlformats.org/drawingml/2006/main">
               <a:ext uri="{FF2B5EF4-FFF2-40B4-BE49-F238E27FC236}">
-                <a16:creationId xmlns:a16="http://schemas.microsoft.com/office/drawing/2014/main" id="{C3F6A381-E90D-431D-8365-51203400471E}"/>
+                <a16:creationId xmlns:a16="http://schemas.microsoft.com/office/drawing/2014/main" id="{7221C477-FF70-43A9-A18E-368256336D1A}"/>
               </a:ext>
             </a:extLst>
           </p:cNvPr>
@@ -2528,7 +2528,7 @@
           <p:cNvPr id="5" name="">
             <a:extLst xmlns:a="http://schemas.openxmlformats.org/drawingml/2006/main">
               <a:ext uri="{FF2B5EF4-FFF2-40B4-BE49-F238E27FC236}">
-                <a16:creationId xmlns:a16="http://schemas.microsoft.com/office/drawing/2014/main" id="{BA9EF599-9B62-4519-A17C-66B16DC79685}"/>
+                <a16:creationId xmlns:a16="http://schemas.microsoft.com/office/drawing/2014/main" id="{082B1ED7-A8C4-4462-B3B1-3EB01FD31B5F}"/>
               </a:ext>
             </a:extLst>
           </p:cNvPr>
@@ -2583,7 +2583,7 @@
     </p:spTree>
     <p:extLst>
       <p:ext uri="{BB962C8B-B14F-4D97-AF65-F5344CB8AC3E}">
-        <p14:creationId xmlns:p14="http://schemas.microsoft.com/office/powerpoint/2010/main" val="62298166"/>
+        <p14:creationId xmlns:p14="http://schemas.microsoft.com/office/powerpoint/2010/main" val="1195812918"/>
       </p:ext>
     </p:extLst>
   </p:cSld>
@@ -2614,7 +2614,7 @@
           <p:cNvPr id="11" name="">
             <a:extLst xmlns:a="http://schemas.openxmlformats.org/drawingml/2006/main">
               <a:ext uri="{FF2B5EF4-FFF2-40B4-BE49-F238E27FC236}">
-                <a16:creationId xmlns:a16="http://schemas.microsoft.com/office/drawing/2014/main" id="{06E8BDD7-4A93-4C91-A210-378267C7A793}"/>
+                <a16:creationId xmlns:a16="http://schemas.microsoft.com/office/drawing/2014/main" id="{BEECC3A1-4F55-4BF1-86E2-8CE42AA1EFA3}"/>
               </a:ext>
             </a:extLst>
           </p:cNvPr>
@@ -2671,7 +2671,7 @@
           <p:cNvPr id="2" name="">
             <a:extLst xmlns:a="http://schemas.openxmlformats.org/drawingml/2006/main">
               <a:ext uri="{FF2B5EF4-FFF2-40B4-BE49-F238E27FC236}">
-                <a16:creationId xmlns:a16="http://schemas.microsoft.com/office/drawing/2014/main" id="{FC6E89C7-02EB-4EE1-96FE-E478F84C3FF1}"/>
+                <a16:creationId xmlns:a16="http://schemas.microsoft.com/office/drawing/2014/main" id="{2705A9C0-4740-4943-9022-EB7B41B80ED9}"/>
               </a:ext>
             </a:extLst>
           </p:cNvPr>
@@ -2728,7 +2728,7 @@
           <p:cNvPr id="3" name="">
             <a:extLst xmlns:a="http://schemas.openxmlformats.org/drawingml/2006/main">
               <a:ext uri="{FF2B5EF4-FFF2-40B4-BE49-F238E27FC236}">
-                <a16:creationId xmlns:a16="http://schemas.microsoft.com/office/drawing/2014/main" id="{79AB0328-F74E-4418-B1B8-B26FCD0096D9}"/>
+                <a16:creationId xmlns:a16="http://schemas.microsoft.com/office/drawing/2014/main" id="{5BE6F12C-418E-4619-B4A5-7273AA6CB9C1}"/>
               </a:ext>
             </a:extLst>
           </p:cNvPr>
@@ -2785,7 +2785,7 @@
           <p:cNvPr id="4" name="">
             <a:extLst xmlns:a="http://schemas.openxmlformats.org/drawingml/2006/main">
               <a:ext uri="{FF2B5EF4-FFF2-40B4-BE49-F238E27FC236}">
-                <a16:creationId xmlns:a16="http://schemas.microsoft.com/office/drawing/2014/main" id="{9C522AC3-E09B-408E-ACAD-4C6DFDCE6D71}"/>
+                <a16:creationId xmlns:a16="http://schemas.microsoft.com/office/drawing/2014/main" id="{5BC83DF4-8F78-4925-A2D0-9ECFD12AA86A}"/>
               </a:ext>
             </a:extLst>
           </p:cNvPr>
@@ -2842,7 +2842,7 @@
           <p:cNvPr id="5" name="">
             <a:extLst xmlns:a="http://schemas.openxmlformats.org/drawingml/2006/main">
               <a:ext uri="{FF2B5EF4-FFF2-40B4-BE49-F238E27FC236}">
-                <a16:creationId xmlns:a16="http://schemas.microsoft.com/office/drawing/2014/main" id="{85DDEE5D-B938-4471-8ADB-20D310C3407F}"/>
+                <a16:creationId xmlns:a16="http://schemas.microsoft.com/office/drawing/2014/main" id="{63F14D6D-9975-4B85-9399-D5348EE9A5DB}"/>
               </a:ext>
             </a:extLst>
           </p:cNvPr>
@@ -2899,7 +2899,7 @@
           <p:cNvPr id="6" name="">
             <a:extLst xmlns:a="http://schemas.openxmlformats.org/drawingml/2006/main">
               <a:ext uri="{FF2B5EF4-FFF2-40B4-BE49-F238E27FC236}">
-                <a16:creationId xmlns:a16="http://schemas.microsoft.com/office/drawing/2014/main" id="{2FF35A60-7E79-4DE8-AC05-A15BD4E725F6}"/>
+                <a16:creationId xmlns:a16="http://schemas.microsoft.com/office/drawing/2014/main" id="{9BF0B363-CCE9-44AE-ADCF-A4EBCCFA2108}"/>
               </a:ext>
             </a:extLst>
           </p:cNvPr>
@@ -2956,7 +2956,7 @@
           <p:cNvPr id="7" name="">
             <a:extLst xmlns:a="http://schemas.openxmlformats.org/drawingml/2006/main">
               <a:ext uri="{FF2B5EF4-FFF2-40B4-BE49-F238E27FC236}">
-                <a16:creationId xmlns:a16="http://schemas.microsoft.com/office/drawing/2014/main" id="{C6069F95-9752-4CCD-AD82-96E9C21B2F47}"/>
+                <a16:creationId xmlns:a16="http://schemas.microsoft.com/office/drawing/2014/main" id="{32389746-5155-4CCE-9828-73C65B973BD2}"/>
               </a:ext>
             </a:extLst>
           </p:cNvPr>
@@ -3013,7 +3013,7 @@
           <p:cNvPr id="8" name="">
             <a:extLst xmlns:a="http://schemas.openxmlformats.org/drawingml/2006/main">
               <a:ext uri="{FF2B5EF4-FFF2-40B4-BE49-F238E27FC236}">
-                <a16:creationId xmlns:a16="http://schemas.microsoft.com/office/drawing/2014/main" id="{898F027E-94FA-4D1C-935F-F0A0D2BB3DA6}"/>
+                <a16:creationId xmlns:a16="http://schemas.microsoft.com/office/drawing/2014/main" id="{4125B5E2-9231-48B6-B572-AAE7C84FA48C}"/>
               </a:ext>
             </a:extLst>
           </p:cNvPr>
@@ -3070,7 +3070,7 @@
           <p:cNvPr id="9" name="">
             <a:extLst xmlns:a="http://schemas.openxmlformats.org/drawingml/2006/main">
               <a:ext uri="{FF2B5EF4-FFF2-40B4-BE49-F238E27FC236}">
-                <a16:creationId xmlns:a16="http://schemas.microsoft.com/office/drawing/2014/main" id="{6F0C6E2E-3712-4920-B749-8D1CA66360EF}"/>
+                <a16:creationId xmlns:a16="http://schemas.microsoft.com/office/drawing/2014/main" id="{44F0D493-2929-4E81-812A-DEA7015ABCEF}"/>
               </a:ext>
             </a:extLst>
           </p:cNvPr>
@@ -3127,7 +3127,7 @@
           <p:cNvPr id="10" name="">
             <a:extLst xmlns:a="http://schemas.openxmlformats.org/drawingml/2006/main">
               <a:ext uri="{FF2B5EF4-FFF2-40B4-BE49-F238E27FC236}">
-                <a16:creationId xmlns:a16="http://schemas.microsoft.com/office/drawing/2014/main" id="{7C71C2D5-7041-4FE4-9E47-45A30E965B09}"/>
+                <a16:creationId xmlns:a16="http://schemas.microsoft.com/office/drawing/2014/main" id="{18A14837-92F8-477E-9963-C7C2BD93446D}"/>
               </a:ext>
             </a:extLst>
           </p:cNvPr>
@@ -3182,7 +3182,7 @@
     </p:spTree>
     <p:extLst>
       <p:ext uri="{BB962C8B-B14F-4D97-AF65-F5344CB8AC3E}">
-        <p14:creationId xmlns:p14="http://schemas.microsoft.com/office/powerpoint/2010/main" val="309207883"/>
+        <p14:creationId xmlns:p14="http://schemas.microsoft.com/office/powerpoint/2010/main" val="511663079"/>
       </p:ext>
     </p:extLst>
   </p:cSld>
@@ -3213,7 +3213,7 @@
           <p:cNvPr id="11" name="">
             <a:extLst xmlns:a="http://schemas.openxmlformats.org/drawingml/2006/main">
               <a:ext uri="{FF2B5EF4-FFF2-40B4-BE49-F238E27FC236}">
-                <a16:creationId xmlns:a16="http://schemas.microsoft.com/office/drawing/2014/main" id="{2D10D7B8-77B8-42F4-8F95-FDF3308B866F}"/>
+                <a16:creationId xmlns:a16="http://schemas.microsoft.com/office/drawing/2014/main" id="{E8889F30-DA6C-45A4-A384-D045CA162078}"/>
               </a:ext>
             </a:extLst>
           </p:cNvPr>
@@ -3270,7 +3270,7 @@
           <p:cNvPr id="2" name="">
             <a:extLst xmlns:a="http://schemas.openxmlformats.org/drawingml/2006/main">
               <a:ext uri="{FF2B5EF4-FFF2-40B4-BE49-F238E27FC236}">
-                <a16:creationId xmlns:a16="http://schemas.microsoft.com/office/drawing/2014/main" id="{A24FE8F7-FFFE-4249-B7EC-4EE0F7B78433}"/>
+                <a16:creationId xmlns:a16="http://schemas.microsoft.com/office/drawing/2014/main" id="{3CF03074-6409-49FC-A803-F98063BEC08F}"/>
               </a:ext>
             </a:extLst>
           </p:cNvPr>
@@ -3327,7 +3327,7 @@
           <p:cNvPr id="3" name="">
             <a:extLst xmlns:a="http://schemas.openxmlformats.org/drawingml/2006/main">
               <a:ext uri="{FF2B5EF4-FFF2-40B4-BE49-F238E27FC236}">
-                <a16:creationId xmlns:a16="http://schemas.microsoft.com/office/drawing/2014/main" id="{5EDECAB4-7ACE-43EC-AD23-6D6F73269864}"/>
+                <a16:creationId xmlns:a16="http://schemas.microsoft.com/office/drawing/2014/main" id="{4F8F9660-436F-41AB-B871-3516B767E955}"/>
               </a:ext>
             </a:extLst>
           </p:cNvPr>
@@ -3384,7 +3384,7 @@
           <p:cNvPr id="4" name="">
             <a:extLst xmlns:a="http://schemas.openxmlformats.org/drawingml/2006/main">
               <a:ext uri="{FF2B5EF4-FFF2-40B4-BE49-F238E27FC236}">
-                <a16:creationId xmlns:a16="http://schemas.microsoft.com/office/drawing/2014/main" id="{69689968-EA67-4278-9529-9FC47C358174}"/>
+                <a16:creationId xmlns:a16="http://schemas.microsoft.com/office/drawing/2014/main" id="{D0630032-848A-47BF-AF73-4CA66A76D44D}"/>
               </a:ext>
             </a:extLst>
           </p:cNvPr>
@@ -3441,7 +3441,7 @@
           <p:cNvPr id="5" name="">
             <a:extLst xmlns:a="http://schemas.openxmlformats.org/drawingml/2006/main">
               <a:ext uri="{FF2B5EF4-FFF2-40B4-BE49-F238E27FC236}">
-                <a16:creationId xmlns:a16="http://schemas.microsoft.com/office/drawing/2014/main" id="{2367DB29-1E79-45A8-BA0D-D4C5C31133B0}"/>
+                <a16:creationId xmlns:a16="http://schemas.microsoft.com/office/drawing/2014/main" id="{3F99673E-4447-4D0B-9BED-A6E6BED15A2A}"/>
               </a:ext>
             </a:extLst>
           </p:cNvPr>
@@ -3498,7 +3498,7 @@
           <p:cNvPr id="6" name="">
             <a:extLst xmlns:a="http://schemas.openxmlformats.org/drawingml/2006/main">
               <a:ext uri="{FF2B5EF4-FFF2-40B4-BE49-F238E27FC236}">
-                <a16:creationId xmlns:a16="http://schemas.microsoft.com/office/drawing/2014/main" id="{8760F0EE-33BB-4A30-A1B5-3133CA1F7E9C}"/>
+                <a16:creationId xmlns:a16="http://schemas.microsoft.com/office/drawing/2014/main" id="{21B5167F-B187-41E4-91BE-37CEA823160F}"/>
               </a:ext>
             </a:extLst>
           </p:cNvPr>
@@ -3555,7 +3555,7 @@
           <p:cNvPr id="7" name="">
             <a:extLst xmlns:a="http://schemas.openxmlformats.org/drawingml/2006/main">
               <a:ext uri="{FF2B5EF4-FFF2-40B4-BE49-F238E27FC236}">
-                <a16:creationId xmlns:a16="http://schemas.microsoft.com/office/drawing/2014/main" id="{ED126ED3-4B78-421A-B8EA-FA52B6B26B06}"/>
+                <a16:creationId xmlns:a16="http://schemas.microsoft.com/office/drawing/2014/main" id="{BCFD6C64-0BA5-4F18-B52E-F9FC79716820}"/>
               </a:ext>
             </a:extLst>
           </p:cNvPr>
@@ -3612,7 +3612,7 @@
           <p:cNvPr id="8" name="">
             <a:extLst xmlns:a="http://schemas.openxmlformats.org/drawingml/2006/main">
               <a:ext uri="{FF2B5EF4-FFF2-40B4-BE49-F238E27FC236}">
-                <a16:creationId xmlns:a16="http://schemas.microsoft.com/office/drawing/2014/main" id="{8EEDDFED-DC11-41FC-BC15-693552ED376D}"/>
+                <a16:creationId xmlns:a16="http://schemas.microsoft.com/office/drawing/2014/main" id="{C7082D0F-9092-43DD-97A0-DF1B5889A6B1}"/>
               </a:ext>
             </a:extLst>
           </p:cNvPr>
@@ -3669,7 +3669,7 @@
           <p:cNvPr id="9" name="">
             <a:extLst xmlns:a="http://schemas.openxmlformats.org/drawingml/2006/main">
               <a:ext uri="{FF2B5EF4-FFF2-40B4-BE49-F238E27FC236}">
-                <a16:creationId xmlns:a16="http://schemas.microsoft.com/office/drawing/2014/main" id="{823630B8-1E34-4EAE-B752-5FE30A20AF6A}"/>
+                <a16:creationId xmlns:a16="http://schemas.microsoft.com/office/drawing/2014/main" id="{CCD171B3-B737-4570-B21F-C554C30C8B84}"/>
               </a:ext>
             </a:extLst>
           </p:cNvPr>
@@ -3726,7 +3726,7 @@
           <p:cNvPr id="10" name="">
             <a:extLst xmlns:a="http://schemas.openxmlformats.org/drawingml/2006/main">
               <a:ext uri="{FF2B5EF4-FFF2-40B4-BE49-F238E27FC236}">
-                <a16:creationId xmlns:a16="http://schemas.microsoft.com/office/drawing/2014/main" id="{C819CD6F-3F13-45E5-BAEC-8D0D0CE208E6}"/>
+                <a16:creationId xmlns:a16="http://schemas.microsoft.com/office/drawing/2014/main" id="{054225E7-B341-4627-AE69-2FFA4927AABA}"/>
               </a:ext>
             </a:extLst>
           </p:cNvPr>
@@ -3781,7 +3781,7 @@
     </p:spTree>
     <p:extLst>
       <p:ext uri="{BB962C8B-B14F-4D97-AF65-F5344CB8AC3E}">
-        <p14:creationId xmlns:p14="http://schemas.microsoft.com/office/powerpoint/2010/main" val="1506089225"/>
+        <p14:creationId xmlns:p14="http://schemas.microsoft.com/office/powerpoint/2010/main" val="1650584842"/>
       </p:ext>
     </p:extLst>
   </p:cSld>
@@ -3812,7 +3812,7 @@
           <p:cNvPr id="8" name="">
             <a:extLst xmlns:a="http://schemas.openxmlformats.org/drawingml/2006/main">
               <a:ext uri="{FF2B5EF4-FFF2-40B4-BE49-F238E27FC236}">
-                <a16:creationId xmlns:a16="http://schemas.microsoft.com/office/drawing/2014/main" id="{BD44967C-3BAD-4B79-AE0F-948CB4A40FF3}"/>
+                <a16:creationId xmlns:a16="http://schemas.microsoft.com/office/drawing/2014/main" id="{99260603-2DBE-4BC5-A2E3-5D9CB9B0DB84}"/>
               </a:ext>
             </a:extLst>
           </p:cNvPr>
@@ -3869,7 +3869,7 @@
           <p:cNvPr id="2" name="">
             <a:extLst xmlns:a="http://schemas.openxmlformats.org/drawingml/2006/main">
               <a:ext uri="{FF2B5EF4-FFF2-40B4-BE49-F238E27FC236}">
-                <a16:creationId xmlns:a16="http://schemas.microsoft.com/office/drawing/2014/main" id="{9AD7D848-2884-4C5E-BE82-D1A3F5FD5B05}"/>
+                <a16:creationId xmlns:a16="http://schemas.microsoft.com/office/drawing/2014/main" id="{67AB63C3-59DC-4C4E-BB26-A9578F90BF2F}"/>
               </a:ext>
             </a:extLst>
           </p:cNvPr>
@@ -3926,7 +3926,7 @@
           <p:cNvPr id="3" name="">
             <a:extLst xmlns:a="http://schemas.openxmlformats.org/drawingml/2006/main">
               <a:ext uri="{FF2B5EF4-FFF2-40B4-BE49-F238E27FC236}">
-                <a16:creationId xmlns:a16="http://schemas.microsoft.com/office/drawing/2014/main" id="{CA4BCEF4-72B7-412C-A578-3ADBD7C50C5F}"/>
+                <a16:creationId xmlns:a16="http://schemas.microsoft.com/office/drawing/2014/main" id="{867BEEDA-C0C0-4BE7-8772-2B56525A5176}"/>
               </a:ext>
             </a:extLst>
           </p:cNvPr>
@@ -3983,7 +3983,7 @@
           <p:cNvPr id="4" name="">
             <a:extLst xmlns:a="http://schemas.openxmlformats.org/drawingml/2006/main">
               <a:ext uri="{FF2B5EF4-FFF2-40B4-BE49-F238E27FC236}">
-                <a16:creationId xmlns:a16="http://schemas.microsoft.com/office/drawing/2014/main" id="{A18CB5D5-B856-4BBE-9C42-566DFD6E5905}"/>
+                <a16:creationId xmlns:a16="http://schemas.microsoft.com/office/drawing/2014/main" id="{3B00DB46-AB85-4422-93B8-4B6FC2E7FAE6}"/>
               </a:ext>
             </a:extLst>
           </p:cNvPr>
@@ -4063,7 +4063,7 @@
           <p:cNvPr id="5" name="">
             <a:extLst xmlns:a="http://schemas.openxmlformats.org/drawingml/2006/main">
               <a:ext uri="{FF2B5EF4-FFF2-40B4-BE49-F238E27FC236}">
-                <a16:creationId xmlns:a16="http://schemas.microsoft.com/office/drawing/2014/main" id="{0FDBC987-1476-4923-BB11-BFB1EDB7C6E0}"/>
+                <a16:creationId xmlns:a16="http://schemas.microsoft.com/office/drawing/2014/main" id="{49B91DC5-109F-44BF-B778-BC73239F743F}"/>
               </a:ext>
             </a:extLst>
           </p:cNvPr>
@@ -4120,7 +4120,7 @@
           <p:cNvPr id="6" name="">
             <a:extLst xmlns:a="http://schemas.openxmlformats.org/drawingml/2006/main">
               <a:ext uri="{FF2B5EF4-FFF2-40B4-BE49-F238E27FC236}">
-                <a16:creationId xmlns:a16="http://schemas.microsoft.com/office/drawing/2014/main" id="{8A92A740-9FC1-4148-9127-45C7E48D4365}"/>
+                <a16:creationId xmlns:a16="http://schemas.microsoft.com/office/drawing/2014/main" id="{595D400A-FA93-41B9-B1EA-782781B12B99}"/>
               </a:ext>
             </a:extLst>
           </p:cNvPr>
@@ -4177,7 +4177,7 @@
           <p:cNvPr id="7" name="">
             <a:extLst xmlns:a="http://schemas.openxmlformats.org/drawingml/2006/main">
               <a:ext uri="{FF2B5EF4-FFF2-40B4-BE49-F238E27FC236}">
-                <a16:creationId xmlns:a16="http://schemas.microsoft.com/office/drawing/2014/main" id="{2A774970-A289-45A3-805B-C5FB721477D7}"/>
+                <a16:creationId xmlns:a16="http://schemas.microsoft.com/office/drawing/2014/main" id="{5BE95D35-7CD5-4E66-8367-D9FBF951B3B8}"/>
               </a:ext>
             </a:extLst>
           </p:cNvPr>
@@ -4255,7 +4255,7 @@
     </p:spTree>
     <p:extLst>
       <p:ext uri="{BB962C8B-B14F-4D97-AF65-F5344CB8AC3E}">
-        <p14:creationId xmlns:p14="http://schemas.microsoft.com/office/powerpoint/2010/main" val="414057381"/>
+        <p14:creationId xmlns:p14="http://schemas.microsoft.com/office/powerpoint/2010/main" val="1338846567"/>
       </p:ext>
     </p:extLst>
   </p:cSld>
@@ -4286,7 +4286,7 @@
           <p:cNvPr id="11" name="">
             <a:extLst xmlns:a="http://schemas.openxmlformats.org/drawingml/2006/main">
               <a:ext uri="{FF2B5EF4-FFF2-40B4-BE49-F238E27FC236}">
-                <a16:creationId xmlns:a16="http://schemas.microsoft.com/office/drawing/2014/main" id="{5B21DD0F-03DE-49B5-9876-A7C5BEAC39ED}"/>
+                <a16:creationId xmlns:a16="http://schemas.microsoft.com/office/drawing/2014/main" id="{F7326894-1EA5-4316-A31D-CF2B412C5007}"/>
               </a:ext>
             </a:extLst>
           </p:cNvPr>
@@ -4343,7 +4343,7 @@
           <p:cNvPr id="2" name="">
             <a:extLst xmlns:a="http://schemas.openxmlformats.org/drawingml/2006/main">
               <a:ext uri="{FF2B5EF4-FFF2-40B4-BE49-F238E27FC236}">
-                <a16:creationId xmlns:a16="http://schemas.microsoft.com/office/drawing/2014/main" id="{5ACABFED-50C1-490B-9608-9F4548782611}"/>
+                <a16:creationId xmlns:a16="http://schemas.microsoft.com/office/drawing/2014/main" id="{5D67655A-1445-45E4-BD7B-6A2B6DB673B8}"/>
               </a:ext>
             </a:extLst>
           </p:cNvPr>
@@ -4400,7 +4400,7 @@
           <p:cNvPr id="3" name="">
             <a:extLst xmlns:a="http://schemas.openxmlformats.org/drawingml/2006/main">
               <a:ext uri="{FF2B5EF4-FFF2-40B4-BE49-F238E27FC236}">
-                <a16:creationId xmlns:a16="http://schemas.microsoft.com/office/drawing/2014/main" id="{D80E0D4C-C191-49B9-90FC-E047BADDF8D4}"/>
+                <a16:creationId xmlns:a16="http://schemas.microsoft.com/office/drawing/2014/main" id="{C21AA945-766B-41FA-8C35-86D764D0DAA5}"/>
               </a:ext>
             </a:extLst>
           </p:cNvPr>
@@ -4457,7 +4457,7 @@
           <p:cNvPr id="4" name="">
             <a:extLst xmlns:a="http://schemas.openxmlformats.org/drawingml/2006/main">
               <a:ext uri="{FF2B5EF4-FFF2-40B4-BE49-F238E27FC236}">
-                <a16:creationId xmlns:a16="http://schemas.microsoft.com/office/drawing/2014/main" id="{AE356D25-BE30-42D2-AB61-0D2168894602}"/>
+                <a16:creationId xmlns:a16="http://schemas.microsoft.com/office/drawing/2014/main" id="{5F3FF08D-A3F5-465E-BDD0-4B1EF45FF8CD}"/>
               </a:ext>
             </a:extLst>
           </p:cNvPr>
@@ -4514,7 +4514,7 @@
           <p:cNvPr id="5" name="">
             <a:extLst xmlns:a="http://schemas.openxmlformats.org/drawingml/2006/main">
               <a:ext uri="{FF2B5EF4-FFF2-40B4-BE49-F238E27FC236}">
-                <a16:creationId xmlns:a16="http://schemas.microsoft.com/office/drawing/2014/main" id="{769C5EDF-89A2-432C-A260-2234ABE92F43}"/>
+                <a16:creationId xmlns:a16="http://schemas.microsoft.com/office/drawing/2014/main" id="{99838282-CE98-47F5-94EB-FBCFA4B618C6}"/>
               </a:ext>
             </a:extLst>
           </p:cNvPr>
@@ -4571,7 +4571,7 @@
           <p:cNvPr id="6" name="">
             <a:extLst xmlns:a="http://schemas.openxmlformats.org/drawingml/2006/main">
               <a:ext uri="{FF2B5EF4-FFF2-40B4-BE49-F238E27FC236}">
-                <a16:creationId xmlns:a16="http://schemas.microsoft.com/office/drawing/2014/main" id="{800E6CDC-5590-44A3-B626-FA1D2BC7BBCE}"/>
+                <a16:creationId xmlns:a16="http://schemas.microsoft.com/office/drawing/2014/main" id="{D25A5D2D-71B8-4580-8557-555B706DDD08}"/>
               </a:ext>
             </a:extLst>
           </p:cNvPr>
@@ -4628,7 +4628,7 @@
           <p:cNvPr id="7" name="">
             <a:extLst xmlns:a="http://schemas.openxmlformats.org/drawingml/2006/main">
               <a:ext uri="{FF2B5EF4-FFF2-40B4-BE49-F238E27FC236}">
-                <a16:creationId xmlns:a16="http://schemas.microsoft.com/office/drawing/2014/main" id="{677D036A-5A0A-48BC-AD1F-CF9339C7FC91}"/>
+                <a16:creationId xmlns:a16="http://schemas.microsoft.com/office/drawing/2014/main" id="{9B0867CD-BF6A-492B-AB8C-75E9A098809D}"/>
               </a:ext>
             </a:extLst>
           </p:cNvPr>
@@ -4685,7 +4685,7 @@
           <p:cNvPr id="8" name="">
             <a:extLst xmlns:a="http://schemas.openxmlformats.org/drawingml/2006/main">
               <a:ext uri="{FF2B5EF4-FFF2-40B4-BE49-F238E27FC236}">
-                <a16:creationId xmlns:a16="http://schemas.microsoft.com/office/drawing/2014/main" id="{15E3CF4E-C699-4622-8FE1-A00CE311C2F0}"/>
+                <a16:creationId xmlns:a16="http://schemas.microsoft.com/office/drawing/2014/main" id="{092F39C6-4EEC-45C3-9DBB-A5219FE4F57A}"/>
               </a:ext>
             </a:extLst>
           </p:cNvPr>
@@ -4742,7 +4742,7 @@
           <p:cNvPr id="9" name="">
             <a:extLst xmlns:a="http://schemas.openxmlformats.org/drawingml/2006/main">
               <a:ext uri="{FF2B5EF4-FFF2-40B4-BE49-F238E27FC236}">
-                <a16:creationId xmlns:a16="http://schemas.microsoft.com/office/drawing/2014/main" id="{D5315244-0DC9-44CC-9430-8F6EF652FC7F}"/>
+                <a16:creationId xmlns:a16="http://schemas.microsoft.com/office/drawing/2014/main" id="{773053D6-CAAD-4ACF-867A-1107AEBC2C52}"/>
               </a:ext>
             </a:extLst>
           </p:cNvPr>
@@ -4799,7 +4799,7 @@
           <p:cNvPr id="10" name="">
             <a:extLst xmlns:a="http://schemas.openxmlformats.org/drawingml/2006/main">
               <a:ext uri="{FF2B5EF4-FFF2-40B4-BE49-F238E27FC236}">
-                <a16:creationId xmlns:a16="http://schemas.microsoft.com/office/drawing/2014/main" id="{0326C1D3-C55A-4666-8D03-24732EB7B8C5}"/>
+                <a16:creationId xmlns:a16="http://schemas.microsoft.com/office/drawing/2014/main" id="{793D4FC0-5EAA-4C16-A47C-C552339A3A46}"/>
               </a:ext>
             </a:extLst>
           </p:cNvPr>
@@ -4854,7 +4854,7 @@
     </p:spTree>
     <p:extLst>
       <p:ext uri="{BB962C8B-B14F-4D97-AF65-F5344CB8AC3E}">
-        <p14:creationId xmlns:p14="http://schemas.microsoft.com/office/powerpoint/2010/main" val="1187783873"/>
+        <p14:creationId xmlns:p14="http://schemas.microsoft.com/office/powerpoint/2010/main" val="22740303"/>
       </p:ext>
     </p:extLst>
   </p:cSld>
@@ -4885,7 +4885,7 @@
           <p:cNvPr id="8" name="">
             <a:extLst xmlns:a="http://schemas.openxmlformats.org/drawingml/2006/main">
               <a:ext uri="{FF2B5EF4-FFF2-40B4-BE49-F238E27FC236}">
-                <a16:creationId xmlns:a16="http://schemas.microsoft.com/office/drawing/2014/main" id="{F11ADD5F-9985-4DD5-998B-0C0BC1BE1AED}"/>
+                <a16:creationId xmlns:a16="http://schemas.microsoft.com/office/drawing/2014/main" id="{04F62993-F5FE-471E-AA5E-3CC6183E1CF1}"/>
               </a:ext>
             </a:extLst>
           </p:cNvPr>
@@ -4942,7 +4942,7 @@
           <p:cNvPr id="2" name="">
             <a:extLst xmlns:a="http://schemas.openxmlformats.org/drawingml/2006/main">
               <a:ext uri="{FF2B5EF4-FFF2-40B4-BE49-F238E27FC236}">
-                <a16:creationId xmlns:a16="http://schemas.microsoft.com/office/drawing/2014/main" id="{DF1CA098-9E16-4439-8C58-895285117272}"/>
+                <a16:creationId xmlns:a16="http://schemas.microsoft.com/office/drawing/2014/main" id="{110DEC36-A3F8-4772-8769-7D0778845086}"/>
               </a:ext>
             </a:extLst>
           </p:cNvPr>
@@ -4999,7 +4999,7 @@
           <p:cNvPr id="3" name="">
             <a:extLst xmlns:a="http://schemas.openxmlformats.org/drawingml/2006/main">
               <a:ext uri="{FF2B5EF4-FFF2-40B4-BE49-F238E27FC236}">
-                <a16:creationId xmlns:a16="http://schemas.microsoft.com/office/drawing/2014/main" id="{8F8CD834-CD32-426E-A253-36C7932A6547}"/>
+                <a16:creationId xmlns:a16="http://schemas.microsoft.com/office/drawing/2014/main" id="{59D39EC1-8754-44CA-A845-8633C8B80C2D}"/>
               </a:ext>
             </a:extLst>
           </p:cNvPr>
@@ -5056,7 +5056,7 @@
           <p:cNvPr id="4" name="">
             <a:extLst xmlns:a="http://schemas.openxmlformats.org/drawingml/2006/main">
               <a:ext uri="{FF2B5EF4-FFF2-40B4-BE49-F238E27FC236}">
-                <a16:creationId xmlns:a16="http://schemas.microsoft.com/office/drawing/2014/main" id="{5A9A3B6A-67D6-4B5B-8A85-A4889336229D}"/>
+                <a16:creationId xmlns:a16="http://schemas.microsoft.com/office/drawing/2014/main" id="{8C824446-1261-4B32-8501-F14098B541E0}"/>
               </a:ext>
             </a:extLst>
           </p:cNvPr>
@@ -5113,7 +5113,7 @@
           <p:cNvPr id="5" name="">
             <a:extLst xmlns:a="http://schemas.openxmlformats.org/drawingml/2006/main">
               <a:ext uri="{FF2B5EF4-FFF2-40B4-BE49-F238E27FC236}">
-                <a16:creationId xmlns:a16="http://schemas.microsoft.com/office/drawing/2014/main" id="{B4909070-EB67-4542-9351-21972CAB82DC}"/>
+                <a16:creationId xmlns:a16="http://schemas.microsoft.com/office/drawing/2014/main" id="{599ACF2F-A480-408F-A2F1-BFB9BCF4B241}"/>
               </a:ext>
             </a:extLst>
           </p:cNvPr>
@@ -5390,7 +5390,7 @@
           <p:cNvPr id="7" name="">
             <a:extLst xmlns:a="http://schemas.openxmlformats.org/drawingml/2006/main">
               <a:ext uri="{FF2B5EF4-FFF2-40B4-BE49-F238E27FC236}">
-                <a16:creationId xmlns:a16="http://schemas.microsoft.com/office/drawing/2014/main" id="{6939E6D9-D3A8-4A9C-9056-D6AAEB5EB5DB}"/>
+                <a16:creationId xmlns:a16="http://schemas.microsoft.com/office/drawing/2014/main" id="{7B89898E-271C-4C84-BCBC-FF85DC3E8CCE}"/>
               </a:ext>
             </a:extLst>
           </p:cNvPr>
@@ -5468,7 +5468,7 @@
     </p:spTree>
     <p:extLst>
       <p:ext uri="{BB962C8B-B14F-4D97-AF65-F5344CB8AC3E}">
-        <p14:creationId xmlns:p14="http://schemas.microsoft.com/office/powerpoint/2010/main" val="84459648"/>
+        <p14:creationId xmlns:p14="http://schemas.microsoft.com/office/powerpoint/2010/main" val="1364714285"/>
       </p:ext>
     </p:extLst>
   </p:cSld>
@@ -5499,7 +5499,7 @@
           <p:cNvPr id="11" name="">
             <a:extLst xmlns:a="http://schemas.openxmlformats.org/drawingml/2006/main">
               <a:ext uri="{FF2B5EF4-FFF2-40B4-BE49-F238E27FC236}">
-                <a16:creationId xmlns:a16="http://schemas.microsoft.com/office/drawing/2014/main" id="{531CDDFA-F6FA-4539-AE11-5EA0876720AD}"/>
+                <a16:creationId xmlns:a16="http://schemas.microsoft.com/office/drawing/2014/main" id="{3FE7A39E-DC4E-43D3-A18D-751A4D532A28}"/>
               </a:ext>
             </a:extLst>
           </p:cNvPr>
@@ -5556,7 +5556,7 @@
           <p:cNvPr id="2" name="">
             <a:extLst xmlns:a="http://schemas.openxmlformats.org/drawingml/2006/main">
               <a:ext uri="{FF2B5EF4-FFF2-40B4-BE49-F238E27FC236}">
-                <a16:creationId xmlns:a16="http://schemas.microsoft.com/office/drawing/2014/main" id="{BDB49E68-B48F-4E2B-A8A9-7D7A52BE5E0C}"/>
+                <a16:creationId xmlns:a16="http://schemas.microsoft.com/office/drawing/2014/main" id="{730FC213-E225-4A42-939E-6D1AF7E53738}"/>
               </a:ext>
             </a:extLst>
           </p:cNvPr>
@@ -5613,7 +5613,7 @@
           <p:cNvPr id="3" name="">
             <a:extLst xmlns:a="http://schemas.openxmlformats.org/drawingml/2006/main">
               <a:ext uri="{FF2B5EF4-FFF2-40B4-BE49-F238E27FC236}">
-                <a16:creationId xmlns:a16="http://schemas.microsoft.com/office/drawing/2014/main" id="{9A4BA59C-10B4-49C8-B6CB-0A8FFA930392}"/>
+                <a16:creationId xmlns:a16="http://schemas.microsoft.com/office/drawing/2014/main" id="{1E86BC89-2A4A-4939-B1D1-B259FE3A733E}"/>
               </a:ext>
             </a:extLst>
           </p:cNvPr>
@@ -5670,7 +5670,7 @@
           <p:cNvPr id="4" name="">
             <a:extLst xmlns:a="http://schemas.openxmlformats.org/drawingml/2006/main">
               <a:ext uri="{FF2B5EF4-FFF2-40B4-BE49-F238E27FC236}">
-                <a16:creationId xmlns:a16="http://schemas.microsoft.com/office/drawing/2014/main" id="{C1F10E46-9ECD-4F90-96E8-53EF67EE1830}"/>
+                <a16:creationId xmlns:a16="http://schemas.microsoft.com/office/drawing/2014/main" id="{99905925-CD35-45AA-BECA-AEB3491599D4}"/>
               </a:ext>
             </a:extLst>
           </p:cNvPr>
@@ -5727,7 +5727,7 @@
           <p:cNvPr id="5" name="">
             <a:extLst xmlns:a="http://schemas.openxmlformats.org/drawingml/2006/main">
               <a:ext uri="{FF2B5EF4-FFF2-40B4-BE49-F238E27FC236}">
-                <a16:creationId xmlns:a16="http://schemas.microsoft.com/office/drawing/2014/main" id="{CAF66EC1-CF16-4B27-A2BF-157A00C1D053}"/>
+                <a16:creationId xmlns:a16="http://schemas.microsoft.com/office/drawing/2014/main" id="{85B47FDC-C23B-477A-AE3D-4EB31A638961}"/>
               </a:ext>
             </a:extLst>
           </p:cNvPr>
@@ -5784,7 +5784,7 @@
           <p:cNvPr id="6" name="">
             <a:extLst xmlns:a="http://schemas.openxmlformats.org/drawingml/2006/main">
               <a:ext uri="{FF2B5EF4-FFF2-40B4-BE49-F238E27FC236}">
-                <a16:creationId xmlns:a16="http://schemas.microsoft.com/office/drawing/2014/main" id="{773FB967-7598-491A-BF66-00DDC8FE7730}"/>
+                <a16:creationId xmlns:a16="http://schemas.microsoft.com/office/drawing/2014/main" id="{00721433-0404-4FD9-B687-C63A9F5F93C3}"/>
               </a:ext>
             </a:extLst>
           </p:cNvPr>
@@ -5841,7 +5841,7 @@
           <p:cNvPr id="7" name="">
             <a:extLst xmlns:a="http://schemas.openxmlformats.org/drawingml/2006/main">
               <a:ext uri="{FF2B5EF4-FFF2-40B4-BE49-F238E27FC236}">
-                <a16:creationId xmlns:a16="http://schemas.microsoft.com/office/drawing/2014/main" id="{DEF75F82-A615-4E59-8963-8266873D32E7}"/>
+                <a16:creationId xmlns:a16="http://schemas.microsoft.com/office/drawing/2014/main" id="{C86F7119-8555-4923-9D82-35B3DDC945A4}"/>
               </a:ext>
             </a:extLst>
           </p:cNvPr>
@@ -5898,7 +5898,7 @@
           <p:cNvPr id="8" name="">
             <a:extLst xmlns:a="http://schemas.openxmlformats.org/drawingml/2006/main">
               <a:ext uri="{FF2B5EF4-FFF2-40B4-BE49-F238E27FC236}">
-                <a16:creationId xmlns:a16="http://schemas.microsoft.com/office/drawing/2014/main" id="{20C14A47-3269-467D-B3F0-9322F23D4A96}"/>
+                <a16:creationId xmlns:a16="http://schemas.microsoft.com/office/drawing/2014/main" id="{0B6B26F8-939B-4831-AFF9-E61D6EBB8EF0}"/>
               </a:ext>
             </a:extLst>
           </p:cNvPr>
@@ -5955,7 +5955,7 @@
           <p:cNvPr id="9" name="">
             <a:extLst xmlns:a="http://schemas.openxmlformats.org/drawingml/2006/main">
               <a:ext uri="{FF2B5EF4-FFF2-40B4-BE49-F238E27FC236}">
-                <a16:creationId xmlns:a16="http://schemas.microsoft.com/office/drawing/2014/main" id="{B76EF42A-85D5-4F5B-990F-F100BA8C94CA}"/>
+                <a16:creationId xmlns:a16="http://schemas.microsoft.com/office/drawing/2014/main" id="{0CE4D999-4C57-4DA3-B96A-92A93F7A4D91}"/>
               </a:ext>
             </a:extLst>
           </p:cNvPr>
@@ -6012,7 +6012,7 @@
           <p:cNvPr id="10" name="">
             <a:extLst xmlns:a="http://schemas.openxmlformats.org/drawingml/2006/main">
               <a:ext uri="{FF2B5EF4-FFF2-40B4-BE49-F238E27FC236}">
-                <a16:creationId xmlns:a16="http://schemas.microsoft.com/office/drawing/2014/main" id="{85F03182-6434-4FD3-B53F-DD7C4F3B4CE9}"/>
+                <a16:creationId xmlns:a16="http://schemas.microsoft.com/office/drawing/2014/main" id="{25848898-00FE-4116-8A5D-C018DD730BEB}"/>
               </a:ext>
             </a:extLst>
           </p:cNvPr>
@@ -6067,7 +6067,7 @@
     </p:spTree>
     <p:extLst>
       <p:ext uri="{BB962C8B-B14F-4D97-AF65-F5344CB8AC3E}">
-        <p14:creationId xmlns:p14="http://schemas.microsoft.com/office/powerpoint/2010/main" val="1351715366"/>
+        <p14:creationId xmlns:p14="http://schemas.microsoft.com/office/powerpoint/2010/main" val="1608104222"/>
       </p:ext>
     </p:extLst>
   </p:cSld>
@@ -6098,7 +6098,7 @@
           <p:cNvPr id="7" name="">
             <a:extLst xmlns:a="http://schemas.openxmlformats.org/drawingml/2006/main">
               <a:ext uri="{FF2B5EF4-FFF2-40B4-BE49-F238E27FC236}">
-                <a16:creationId xmlns:a16="http://schemas.microsoft.com/office/drawing/2014/main" id="{71CB1DC2-D07C-4CB4-820A-50FE3C0F47C1}"/>
+                <a16:creationId xmlns:a16="http://schemas.microsoft.com/office/drawing/2014/main" id="{AA4CA1A4-DC0F-4C40-AB72-37D5AE048259}"/>
               </a:ext>
             </a:extLst>
           </p:cNvPr>
@@ -6155,7 +6155,7 @@
           <p:cNvPr id="2" name="">
             <a:extLst xmlns:a="http://schemas.openxmlformats.org/drawingml/2006/main">
               <a:ext uri="{FF2B5EF4-FFF2-40B4-BE49-F238E27FC236}">
-                <a16:creationId xmlns:a16="http://schemas.microsoft.com/office/drawing/2014/main" id="{23DDF14E-BFDF-431A-8F02-6525483CA0B2}"/>
+                <a16:creationId xmlns:a16="http://schemas.microsoft.com/office/drawing/2014/main" id="{9C51C3EC-2E36-4DF2-923B-FC035200E2E9}"/>
               </a:ext>
             </a:extLst>
           </p:cNvPr>
@@ -6212,7 +6212,7 @@
           <p:cNvPr id="3" name="">
             <a:extLst xmlns:a="http://schemas.openxmlformats.org/drawingml/2006/main">
               <a:ext uri="{FF2B5EF4-FFF2-40B4-BE49-F238E27FC236}">
-                <a16:creationId xmlns:a16="http://schemas.microsoft.com/office/drawing/2014/main" id="{1F01F45B-DF51-4C13-A324-3B5057D84CE3}"/>
+                <a16:creationId xmlns:a16="http://schemas.microsoft.com/office/drawing/2014/main" id="{C247E335-AACB-4E70-BA95-7B61FA1E9093}"/>
               </a:ext>
             </a:extLst>
           </p:cNvPr>
@@ -6685,7 +6685,7 @@
           <p:cNvPr id="5" name="">
             <a:extLst xmlns:a="http://schemas.openxmlformats.org/drawingml/2006/main">
               <a:ext uri="{FF2B5EF4-FFF2-40B4-BE49-F238E27FC236}">
-                <a16:creationId xmlns:a16="http://schemas.microsoft.com/office/drawing/2014/main" id="{B9ABF171-088C-487F-ABB3-F61984D07CDE}"/>
+                <a16:creationId xmlns:a16="http://schemas.microsoft.com/office/drawing/2014/main" id="{F9DCB552-E447-411A-985F-35EB68EC06F6}"/>
               </a:ext>
             </a:extLst>
           </p:cNvPr>
@@ -6765,7 +6765,7 @@
           <p:cNvPr id="6" name="">
             <a:extLst xmlns:a="http://schemas.openxmlformats.org/drawingml/2006/main">
               <a:ext uri="{FF2B5EF4-FFF2-40B4-BE49-F238E27FC236}">
-                <a16:creationId xmlns:a16="http://schemas.microsoft.com/office/drawing/2014/main" id="{18270E02-7E9E-438B-9C89-27959BC94AAF}"/>
+                <a16:creationId xmlns:a16="http://schemas.microsoft.com/office/drawing/2014/main" id="{A3457BFD-8743-4537-8E2B-5CB210F95F9C}"/>
               </a:ext>
             </a:extLst>
           </p:cNvPr>
@@ -6820,7 +6820,7 @@
     </p:spTree>
     <p:extLst>
       <p:ext uri="{BB962C8B-B14F-4D97-AF65-F5344CB8AC3E}">
-        <p14:creationId xmlns:p14="http://schemas.microsoft.com/office/powerpoint/2010/main" val="1007828946"/>
+        <p14:creationId xmlns:p14="http://schemas.microsoft.com/office/powerpoint/2010/main" val="157739023"/>
       </p:ext>
     </p:extLst>
   </p:cSld>
@@ -6851,7 +6851,7 @@
           <p:cNvPr id="7" name="">
             <a:extLst xmlns:a="http://schemas.openxmlformats.org/drawingml/2006/main">
               <a:ext uri="{FF2B5EF4-FFF2-40B4-BE49-F238E27FC236}">
-                <a16:creationId xmlns:a16="http://schemas.microsoft.com/office/drawing/2014/main" id="{7F2DCB22-308A-46FD-ADF6-6C17178EA3B7}"/>
+                <a16:creationId xmlns:a16="http://schemas.microsoft.com/office/drawing/2014/main" id="{A2DE46B8-CE04-4B3E-BA61-5172246671DE}"/>
               </a:ext>
             </a:extLst>
           </p:cNvPr>
@@ -6908,7 +6908,7 @@
           <p:cNvPr id="2" name="">
             <a:extLst xmlns:a="http://schemas.openxmlformats.org/drawingml/2006/main">
               <a:ext uri="{FF2B5EF4-FFF2-40B4-BE49-F238E27FC236}">
-                <a16:creationId xmlns:a16="http://schemas.microsoft.com/office/drawing/2014/main" id="{9A96011C-8EB8-4D22-826F-612F8F796FD7}"/>
+                <a16:creationId xmlns:a16="http://schemas.microsoft.com/office/drawing/2014/main" id="{1FEF32D4-99F0-425F-8AC6-1392868CCD0F}"/>
               </a:ext>
             </a:extLst>
           </p:cNvPr>
@@ -6965,7 +6965,7 @@
           <p:cNvPr id="3" name="">
             <a:extLst xmlns:a="http://schemas.openxmlformats.org/drawingml/2006/main">
               <a:ext uri="{FF2B5EF4-FFF2-40B4-BE49-F238E27FC236}">
-                <a16:creationId xmlns:a16="http://schemas.microsoft.com/office/drawing/2014/main" id="{730A36C9-9739-4F5F-BB31-DE2DDE3A5735}"/>
+                <a16:creationId xmlns:a16="http://schemas.microsoft.com/office/drawing/2014/main" id="{F71F21CE-DC1E-4B06-A64D-2FBDF8B81E70}"/>
               </a:ext>
             </a:extLst>
           </p:cNvPr>
@@ -7029,7 +7029,7 @@
         </p:xfrm>
         <a:graphic xmlns:a="http://schemas.openxmlformats.org/drawingml/2006/main">
           <a:graphicData uri="http://schemas.openxmlformats.org/drawingml/2006/chart">
-            <c:chart xmlns:r="http://schemas.openxmlformats.org/officeDocument/2006/relationships" xmlns:c="http://schemas.openxmlformats.org/drawingml/2006/chart" r:id="R6fe86116c9954361"/>
+            <c:chart xmlns:r="http://schemas.openxmlformats.org/officeDocument/2006/relationships" xmlns:c="http://schemas.openxmlformats.org/drawingml/2006/chart" r:id="Rffc90f7572e34e21"/>
           </a:graphicData>
         </a:graphic>
       </p:graphicFrame>
@@ -7038,7 +7038,7 @@
           <p:cNvPr id="5" name="">
             <a:extLst xmlns:a="http://schemas.openxmlformats.org/drawingml/2006/main">
               <a:ext uri="{FF2B5EF4-FFF2-40B4-BE49-F238E27FC236}">
-                <a16:creationId xmlns:a16="http://schemas.microsoft.com/office/drawing/2014/main" id="{7BC658AD-7AEC-45FF-89DD-2EA15E17D6AD}"/>
+                <a16:creationId xmlns:a16="http://schemas.microsoft.com/office/drawing/2014/main" id="{D74809A5-C772-40FC-9A92-015CC8B4D661}"/>
               </a:ext>
             </a:extLst>
           </p:cNvPr>
@@ -7095,7 +7095,7 @@
           <p:cNvPr id="6" name="">
             <a:extLst xmlns:a="http://schemas.openxmlformats.org/drawingml/2006/main">
               <a:ext uri="{FF2B5EF4-FFF2-40B4-BE49-F238E27FC236}">
-                <a16:creationId xmlns:a16="http://schemas.microsoft.com/office/drawing/2014/main" id="{1BBCA8CE-0ECD-4793-9A88-B852554A0680}"/>
+                <a16:creationId xmlns:a16="http://schemas.microsoft.com/office/drawing/2014/main" id="{4780754B-9E9F-4CA1-A87E-2860D9E7727D}"/>
               </a:ext>
             </a:extLst>
           </p:cNvPr>
@@ -7150,7 +7150,7 @@
     </p:spTree>
     <p:extLst>
       <p:ext uri="{BB962C8B-B14F-4D97-AF65-F5344CB8AC3E}">
-        <p14:creationId xmlns:p14="http://schemas.microsoft.com/office/powerpoint/2010/main" val="913595061"/>
+        <p14:creationId xmlns:p14="http://schemas.microsoft.com/office/powerpoint/2010/main" val="1112509993"/>
       </p:ext>
     </p:extLst>
   </p:cSld>
@@ -7181,7 +7181,7 @@
           <p:cNvPr id="7" name="">
             <a:extLst xmlns:a="http://schemas.openxmlformats.org/drawingml/2006/main">
               <a:ext uri="{FF2B5EF4-FFF2-40B4-BE49-F238E27FC236}">
-                <a16:creationId xmlns:a16="http://schemas.microsoft.com/office/drawing/2014/main" id="{603E0C46-F4CE-40AE-ABFA-3661F15BF5AC}"/>
+                <a16:creationId xmlns:a16="http://schemas.microsoft.com/office/drawing/2014/main" id="{20418400-6484-4B3A-AEC1-594E94B2C3EC}"/>
               </a:ext>
             </a:extLst>
           </p:cNvPr>
@@ -7238,7 +7238,7 @@
           <p:cNvPr id="2" name="">
             <a:extLst xmlns:a="http://schemas.openxmlformats.org/drawingml/2006/main">
               <a:ext uri="{FF2B5EF4-FFF2-40B4-BE49-F238E27FC236}">
-                <a16:creationId xmlns:a16="http://schemas.microsoft.com/office/drawing/2014/main" id="{1824ECEA-FFBC-4329-8D9B-6A045E56DCD9}"/>
+                <a16:creationId xmlns:a16="http://schemas.microsoft.com/office/drawing/2014/main" id="{C96F00CE-895F-491F-8F2D-A9C5FE7A5D99}"/>
               </a:ext>
             </a:extLst>
           </p:cNvPr>
@@ -7295,7 +7295,7 @@
           <p:cNvPr id="3" name="">
             <a:extLst xmlns:a="http://schemas.openxmlformats.org/drawingml/2006/main">
               <a:ext uri="{FF2B5EF4-FFF2-40B4-BE49-F238E27FC236}">
-                <a16:creationId xmlns:a16="http://schemas.microsoft.com/office/drawing/2014/main" id="{F95557DD-AEAD-4CE0-9F36-A6E619EF44A8}"/>
+                <a16:creationId xmlns:a16="http://schemas.microsoft.com/office/drawing/2014/main" id="{25B1AC15-EDFD-4ADE-953A-3C843CD0BB10}"/>
               </a:ext>
             </a:extLst>
           </p:cNvPr>
@@ -7866,7 +7866,7 @@
           <p:cNvPr id="5" name="">
             <a:extLst xmlns:a="http://schemas.openxmlformats.org/drawingml/2006/main">
               <a:ext uri="{FF2B5EF4-FFF2-40B4-BE49-F238E27FC236}">
-                <a16:creationId xmlns:a16="http://schemas.microsoft.com/office/drawing/2014/main" id="{9B7CB842-7B91-4C1C-9330-D82DB2DBCC01}"/>
+                <a16:creationId xmlns:a16="http://schemas.microsoft.com/office/drawing/2014/main" id="{1A0BB303-6682-4376-977E-CA0BBD78F23F}"/>
               </a:ext>
             </a:extLst>
           </p:cNvPr>
@@ -7923,7 +7923,7 @@
           <p:cNvPr id="6" name="">
             <a:extLst xmlns:a="http://schemas.openxmlformats.org/drawingml/2006/main">
               <a:ext uri="{FF2B5EF4-FFF2-40B4-BE49-F238E27FC236}">
-                <a16:creationId xmlns:a16="http://schemas.microsoft.com/office/drawing/2014/main" id="{48F60CF0-10C7-4D57-B9F8-CA6575D2A622}"/>
+                <a16:creationId xmlns:a16="http://schemas.microsoft.com/office/drawing/2014/main" id="{9E35494F-6F3D-423D-B7D3-899E7C7AC025}"/>
               </a:ext>
             </a:extLst>
           </p:cNvPr>
@@ -7978,7 +7978,7 @@
     </p:spTree>
     <p:extLst>
       <p:ext uri="{BB962C8B-B14F-4D97-AF65-F5344CB8AC3E}">
-        <p14:creationId xmlns:p14="http://schemas.microsoft.com/office/powerpoint/2010/main" val="1446607800"/>
+        <p14:creationId xmlns:p14="http://schemas.microsoft.com/office/powerpoint/2010/main" val="1036344301"/>
       </p:ext>
     </p:extLst>
   </p:cSld>
@@ -8009,7 +8009,7 @@
           <p:cNvPr id="10" name="">
             <a:extLst xmlns:a="http://schemas.openxmlformats.org/drawingml/2006/main">
               <a:ext uri="{FF2B5EF4-FFF2-40B4-BE49-F238E27FC236}">
-                <a16:creationId xmlns:a16="http://schemas.microsoft.com/office/drawing/2014/main" id="{2E183ABF-F87A-40A4-BD6A-C9988F7FC423}"/>
+                <a16:creationId xmlns:a16="http://schemas.microsoft.com/office/drawing/2014/main" id="{FA5D1B6D-F195-4437-8CDA-562608416F96}"/>
               </a:ext>
             </a:extLst>
           </p:cNvPr>
@@ -8066,7 +8066,7 @@
           <p:cNvPr id="2" name="">
             <a:extLst xmlns:a="http://schemas.openxmlformats.org/drawingml/2006/main">
               <a:ext uri="{FF2B5EF4-FFF2-40B4-BE49-F238E27FC236}">
-                <a16:creationId xmlns:a16="http://schemas.microsoft.com/office/drawing/2014/main" id="{D82B1A36-CC29-4BDA-95BE-E78FFADADBCA}"/>
+                <a16:creationId xmlns:a16="http://schemas.microsoft.com/office/drawing/2014/main" id="{6FB33E7E-0DCA-4EB8-8BE8-1B712A016294}"/>
               </a:ext>
             </a:extLst>
           </p:cNvPr>
@@ -8123,7 +8123,7 @@
           <p:cNvPr id="3" name="">
             <a:extLst xmlns:a="http://schemas.openxmlformats.org/drawingml/2006/main">
               <a:ext uri="{FF2B5EF4-FFF2-40B4-BE49-F238E27FC236}">
-                <a16:creationId xmlns:a16="http://schemas.microsoft.com/office/drawing/2014/main" id="{6D7161AA-0F37-43C6-9A59-DD69F4DEE324}"/>
+                <a16:creationId xmlns:a16="http://schemas.microsoft.com/office/drawing/2014/main" id="{0A9CEB13-8676-4583-A0BB-913113F73C65}"/>
               </a:ext>
             </a:extLst>
           </p:cNvPr>
@@ -8425,7 +8425,7 @@
           <p:cNvPr id="5" name="">
             <a:extLst xmlns:a="http://schemas.openxmlformats.org/drawingml/2006/main">
               <a:ext uri="{FF2B5EF4-FFF2-40B4-BE49-F238E27FC236}">
-                <a16:creationId xmlns:a16="http://schemas.microsoft.com/office/drawing/2014/main" id="{0588DB02-C229-4BCA-9323-7BFFD1A55346}"/>
+                <a16:creationId xmlns:a16="http://schemas.microsoft.com/office/drawing/2014/main" id="{ECC82B88-A29F-494C-9413-FAA91D73BD23}"/>
               </a:ext>
             </a:extLst>
           </p:cNvPr>
@@ -8482,7 +8482,7 @@
           <p:cNvPr id="6" name="">
             <a:extLst xmlns:a="http://schemas.openxmlformats.org/drawingml/2006/main">
               <a:ext uri="{FF2B5EF4-FFF2-40B4-BE49-F238E27FC236}">
-                <a16:creationId xmlns:a16="http://schemas.microsoft.com/office/drawing/2014/main" id="{55B6CC6B-4C97-4204-8781-8D2D933C46C5}"/>
+                <a16:creationId xmlns:a16="http://schemas.microsoft.com/office/drawing/2014/main" id="{2B64C17D-C2EF-4511-A814-FF428C8736CA}"/>
               </a:ext>
             </a:extLst>
           </p:cNvPr>
@@ -8539,7 +8539,7 @@
           <p:cNvPr id="7" name="">
             <a:extLst xmlns:a="http://schemas.openxmlformats.org/drawingml/2006/main">
               <a:ext uri="{FF2B5EF4-FFF2-40B4-BE49-F238E27FC236}">
-                <a16:creationId xmlns:a16="http://schemas.microsoft.com/office/drawing/2014/main" id="{E1A8B894-35B8-49DA-BE97-A32A1094EDA7}"/>
+                <a16:creationId xmlns:a16="http://schemas.microsoft.com/office/drawing/2014/main" id="{A1A7947C-7114-4055-B386-EFD304228A78}"/>
               </a:ext>
             </a:extLst>
           </p:cNvPr>
@@ -8596,7 +8596,7 @@
           <p:cNvPr id="8" name="">
             <a:extLst xmlns:a="http://schemas.openxmlformats.org/drawingml/2006/main">
               <a:ext uri="{FF2B5EF4-FFF2-40B4-BE49-F238E27FC236}">
-                <a16:creationId xmlns:a16="http://schemas.microsoft.com/office/drawing/2014/main" id="{1BF9AC2F-D09E-4D49-941E-AB198421C027}"/>
+                <a16:creationId xmlns:a16="http://schemas.microsoft.com/office/drawing/2014/main" id="{DC456DFC-F6E0-4941-8CF5-92D93E8E1BFC}"/>
               </a:ext>
             </a:extLst>
           </p:cNvPr>
@@ -8653,7 +8653,7 @@
           <p:cNvPr id="9" name="">
             <a:extLst xmlns:a="http://schemas.openxmlformats.org/drawingml/2006/main">
               <a:ext uri="{FF2B5EF4-FFF2-40B4-BE49-F238E27FC236}">
-                <a16:creationId xmlns:a16="http://schemas.microsoft.com/office/drawing/2014/main" id="{83131933-ED53-47D5-BDB1-715E394E5FB4}"/>
+                <a16:creationId xmlns:a16="http://schemas.microsoft.com/office/drawing/2014/main" id="{32C1BAD6-4224-4DFB-AB00-6AC5D74EB4AE}"/>
               </a:ext>
             </a:extLst>
           </p:cNvPr>
@@ -8708,7 +8708,7 @@
     </p:spTree>
     <p:extLst>
       <p:ext uri="{BB962C8B-B14F-4D97-AF65-F5344CB8AC3E}">
-        <p14:creationId xmlns:p14="http://schemas.microsoft.com/office/powerpoint/2010/main" val="2033955633"/>
+        <p14:creationId xmlns:p14="http://schemas.microsoft.com/office/powerpoint/2010/main" val="338382551"/>
       </p:ext>
     </p:extLst>
   </p:cSld>
@@ -8739,7 +8739,7 @@
           <p:cNvPr id="7" name="">
             <a:extLst xmlns:a="http://schemas.openxmlformats.org/drawingml/2006/main">
               <a:ext uri="{FF2B5EF4-FFF2-40B4-BE49-F238E27FC236}">
-                <a16:creationId xmlns:a16="http://schemas.microsoft.com/office/drawing/2014/main" id="{7EFD6842-ADAA-4F7C-BCC9-726DC3FD2BD0}"/>
+                <a16:creationId xmlns:a16="http://schemas.microsoft.com/office/drawing/2014/main" id="{B160F53B-39AE-432D-872C-308CB2015FAB}"/>
               </a:ext>
             </a:extLst>
           </p:cNvPr>
@@ -8796,7 +8796,7 @@
           <p:cNvPr id="2" name="">
             <a:extLst xmlns:a="http://schemas.openxmlformats.org/drawingml/2006/main">
               <a:ext uri="{FF2B5EF4-FFF2-40B4-BE49-F238E27FC236}">
-                <a16:creationId xmlns:a16="http://schemas.microsoft.com/office/drawing/2014/main" id="{97765610-5E06-47E0-A60B-7AAC036D6D2A}"/>
+                <a16:creationId xmlns:a16="http://schemas.microsoft.com/office/drawing/2014/main" id="{F31BB291-BC2F-48A5-B92C-8C776A86F589}"/>
               </a:ext>
             </a:extLst>
           </p:cNvPr>
@@ -8853,7 +8853,7 @@
           <p:cNvPr id="3" name="">
             <a:extLst xmlns:a="http://schemas.openxmlformats.org/drawingml/2006/main">
               <a:ext uri="{FF2B5EF4-FFF2-40B4-BE49-F238E27FC236}">
-                <a16:creationId xmlns:a16="http://schemas.microsoft.com/office/drawing/2014/main" id="{2F16F964-6BB9-40FE-9D22-A2EAFBF1039A}"/>
+                <a16:creationId xmlns:a16="http://schemas.microsoft.com/office/drawing/2014/main" id="{A0165E0F-6D0A-4786-A0CF-1C883A54A235}"/>
               </a:ext>
             </a:extLst>
           </p:cNvPr>
@@ -8917,7 +8917,7 @@
         </p:xfrm>
         <a:graphic xmlns:a="http://schemas.openxmlformats.org/drawingml/2006/main">
           <a:graphicData uri="http://schemas.openxmlformats.org/drawingml/2006/chart">
-            <c:chart xmlns:r="http://schemas.openxmlformats.org/officeDocument/2006/relationships" xmlns:c="http://schemas.openxmlformats.org/drawingml/2006/chart" r:id="R475c3127b55a4e48"/>
+            <c:chart xmlns:r="http://schemas.openxmlformats.org/officeDocument/2006/relationships" xmlns:c="http://schemas.openxmlformats.org/drawingml/2006/chart" r:id="Rda3393f5d3574fd9"/>
           </a:graphicData>
         </a:graphic>
       </p:graphicFrame>
@@ -8926,7 +8926,7 @@
           <p:cNvPr id="5" name="">
             <a:extLst xmlns:a="http://schemas.openxmlformats.org/drawingml/2006/main">
               <a:ext uri="{FF2B5EF4-FFF2-40B4-BE49-F238E27FC236}">
-                <a16:creationId xmlns:a16="http://schemas.microsoft.com/office/drawing/2014/main" id="{E3B031B6-2B6A-4189-A59A-BE341B233D22}"/>
+                <a16:creationId xmlns:a16="http://schemas.microsoft.com/office/drawing/2014/main" id="{9799951B-4DF8-42ED-AD70-3422A751AE6F}"/>
               </a:ext>
             </a:extLst>
           </p:cNvPr>
@@ -8983,7 +8983,7 @@
           <p:cNvPr id="6" name="">
             <a:extLst xmlns:a="http://schemas.openxmlformats.org/drawingml/2006/main">
               <a:ext uri="{FF2B5EF4-FFF2-40B4-BE49-F238E27FC236}">
-                <a16:creationId xmlns:a16="http://schemas.microsoft.com/office/drawing/2014/main" id="{A508ABD1-3A78-414C-97F6-85B0F50CE52F}"/>
+                <a16:creationId xmlns:a16="http://schemas.microsoft.com/office/drawing/2014/main" id="{03AAF85F-81C6-40F1-BBAC-FBA4D979E206}"/>
               </a:ext>
             </a:extLst>
           </p:cNvPr>
@@ -9038,7 +9038,7 @@
     </p:spTree>
     <p:extLst>
       <p:ext uri="{BB962C8B-B14F-4D97-AF65-F5344CB8AC3E}">
-        <p14:creationId xmlns:p14="http://schemas.microsoft.com/office/powerpoint/2010/main" val="1325381059"/>
+        <p14:creationId xmlns:p14="http://schemas.microsoft.com/office/powerpoint/2010/main" val="2041144991"/>
       </p:ext>
     </p:extLst>
   </p:cSld>

</xml_diff>